<commit_message>
latest progress update to slides
</commit_message>
<xml_diff>
--- a/progress_checkin.pptx
+++ b/progress_checkin.pptx
@@ -4727,84 +4727,6 @@
       </p:sp>
       <p:sp>
         <p:nvSpPr>
-          <p:cNvPr id="120" name="Shape 41">
-            <a:extLst>
-              <a:ext uri="{FF2B5EF4-FFF2-40B4-BE49-F238E27FC236}">
-                <a16:creationId xmlns:a16="http://schemas.microsoft.com/office/drawing/2014/main" id="{E20A99A8-0E82-DB33-E28F-6FDF8668713A}"/>
-              </a:ext>
-            </a:extLst>
-          </p:cNvPr>
-          <p:cNvSpPr/>
-          <p:nvPr/>
-        </p:nvSpPr>
-        <p:spPr>
-          <a:xfrm>
-            <a:off x="543560" y="4105656"/>
-            <a:ext cx="594360" cy="164592"/>
-          </a:xfrm>
-          <a:prstGeom prst="rect">
-            <a:avLst/>
-          </a:prstGeom>
-          <a:solidFill>
-            <a:srgbClr val="F1C40F">
-              <a:alpha val="20000"/>
-            </a:srgbClr>
-          </a:solidFill>
-          <a:ln/>
-        </p:spPr>
-        <p:txBody>
-          <a:bodyPr/>
-          <a:lstStyle/>
-          <a:p>
-            <a:endParaRPr lang="en-US" dirty="0"/>
-          </a:p>
-        </p:txBody>
-      </p:sp>
-      <p:sp>
-        <p:nvSpPr>
-          <p:cNvPr id="121" name="Text 48">
-            <a:extLst>
-              <a:ext uri="{FF2B5EF4-FFF2-40B4-BE49-F238E27FC236}">
-                <a16:creationId xmlns:a16="http://schemas.microsoft.com/office/drawing/2014/main" id="{A305A59E-C93A-E925-61C1-5CF4D8DEA13A}"/>
-              </a:ext>
-            </a:extLst>
-          </p:cNvPr>
-          <p:cNvSpPr/>
-          <p:nvPr/>
-        </p:nvSpPr>
-        <p:spPr>
-          <a:xfrm>
-            <a:off x="541528" y="4091940"/>
-            <a:ext cx="594360" cy="201168"/>
-          </a:xfrm>
-          <a:prstGeom prst="rect">
-            <a:avLst/>
-          </a:prstGeom>
-          <a:noFill/>
-          <a:ln/>
-        </p:spPr>
-        <p:txBody>
-          <a:bodyPr wrap="square" lIns="0" tIns="0" rIns="0" bIns="0" rtlCol="0" anchor="ctr"/>
-          <a:lstStyle/>
-          <a:p>
-            <a:pPr algn="ctr"/>
-            <a:r>
-              <a:rPr lang="en-US" sz="700" b="1" dirty="0">
-                <a:solidFill>
-                  <a:srgbClr val="F1C40F"/>
-                </a:solidFill>
-                <a:latin typeface="Calibri" pitchFamily="34" charset="0"/>
-                <a:ea typeface="Calibri" pitchFamily="34" charset="-122"/>
-                <a:cs typeface="Calibri" pitchFamily="34" charset="-120"/>
-              </a:rPr>
-              <a:t>IN PROG</a:t>
-            </a:r>
-            <a:endParaRPr lang="en-US" sz="700" dirty="0"/>
-          </a:p>
-        </p:txBody>
-      </p:sp>
-      <p:sp>
-        <p:nvSpPr>
           <p:cNvPr id="128" name="Text 16">
             <a:extLst>
               <a:ext uri="{FF2B5EF4-FFF2-40B4-BE49-F238E27FC236}">
@@ -5226,6 +5148,86 @@
                 <a:cs typeface="Calibri" pitchFamily="34" charset="-120"/>
               </a:rPr>
               <a:t>IN PROG</a:t>
+            </a:r>
+            <a:endParaRPr lang="en-US" sz="700" dirty="0"/>
+          </a:p>
+        </p:txBody>
+      </p:sp>
+      <p:sp>
+        <p:nvSpPr>
+          <p:cNvPr id="37" name="Shape 27">
+            <a:extLst>
+              <a:ext uri="{FF2B5EF4-FFF2-40B4-BE49-F238E27FC236}">
+                <a16:creationId xmlns:a16="http://schemas.microsoft.com/office/drawing/2014/main" id="{E47BFD65-7E54-DC55-FBAB-948C0AD31936}"/>
+              </a:ext>
+            </a:extLst>
+          </p:cNvPr>
+          <p:cNvSpPr/>
+          <p:nvPr/>
+        </p:nvSpPr>
+        <p:spPr>
+          <a:xfrm>
+            <a:off x="567648" y="4091092"/>
+            <a:ext cx="594360" cy="164592"/>
+          </a:xfrm>
+          <a:prstGeom prst="rect">
+            <a:avLst/>
+          </a:prstGeom>
+          <a:solidFill>
+            <a:srgbClr val="2ECC71">
+              <a:alpha val="20000"/>
+            </a:srgbClr>
+          </a:solidFill>
+          <a:ln/>
+        </p:spPr>
+        <p:txBody>
+          <a:bodyPr/>
+          <a:lstStyle/>
+          <a:p>
+            <a:endParaRPr lang="en-US" dirty="0"/>
+          </a:p>
+        </p:txBody>
+      </p:sp>
+      <p:sp>
+        <p:nvSpPr>
+          <p:cNvPr id="43" name="Text 28">
+            <a:extLst>
+              <a:ext uri="{FF2B5EF4-FFF2-40B4-BE49-F238E27FC236}">
+                <a16:creationId xmlns:a16="http://schemas.microsoft.com/office/drawing/2014/main" id="{1213F7BC-CE34-CC3B-D0BB-B862A8607A9D}"/>
+              </a:ext>
+            </a:extLst>
+          </p:cNvPr>
+          <p:cNvSpPr/>
+          <p:nvPr/>
+        </p:nvSpPr>
+        <p:spPr>
+          <a:xfrm>
+            <a:off x="548640" y="4069080"/>
+            <a:ext cx="594360" cy="201168"/>
+          </a:xfrm>
+          <a:prstGeom prst="rect">
+            <a:avLst/>
+          </a:prstGeom>
+          <a:noFill/>
+          <a:ln/>
+        </p:spPr>
+        <p:txBody>
+          <a:bodyPr wrap="square" lIns="0" tIns="0" rIns="0" bIns="0" rtlCol="0" anchor="ctr"/>
+          <a:lstStyle/>
+          <a:p>
+            <a:pPr marL="0" indent="0" algn="ctr">
+              <a:buNone/>
+            </a:pPr>
+            <a:r>
+              <a:rPr lang="en-US" sz="700" b="1" dirty="0">
+                <a:solidFill>
+                  <a:srgbClr val="2ECC71"/>
+                </a:solidFill>
+                <a:latin typeface="Calibri" pitchFamily="34" charset="0"/>
+                <a:ea typeface="Calibri" pitchFamily="34" charset="-122"/>
+                <a:cs typeface="Calibri" pitchFamily="34" charset="-120"/>
+              </a:rPr>
+              <a:t>DONE</a:t>
             </a:r>
             <a:endParaRPr lang="en-US" sz="700" dirty="0"/>
           </a:p>

</xml_diff>